<commit_message>
docs: finalize MVP closure report and project status
</commit_message>
<xml_diff>
--- a/docs/reports/output/AI-Digest-結案報告.pptx
+++ b/docs/reports/output/AI-Digest-結案報告.pptx
@@ -4623,6 +4623,48 @@
         </p:nvSpPr>
         <p:spPr>
           <a:xfrm>
+            <a:off x="594360" y="4407408"/>
+            <a:ext cx="5212080" cy="457200"/>
+          </a:xfrm>
+          <a:prstGeom prst="rect">
+            <a:avLst/>
+          </a:prstGeom>
+          <a:noFill/>
+        </p:spPr>
+        <p:txBody>
+          <a:bodyPr wrap="square" lIns="0" rIns="0" tIns="0" bIns="0">
+            <a:spAutoFit/>
+          </a:bodyPr>
+          <a:lstStyle/>
+          <a:p>
+            <a:pPr>
+              <a:spcAft>
+                <a:spcPts val="500"/>
+              </a:spcAft>
+              <a:defRPr sz="1800" b="0">
+                <a:solidFill>
+                  <a:srgbClr val="173D32"/>
+                </a:solidFill>
+                <a:latin typeface="Microsoft JhengHei"/>
+              </a:defRPr>
+            </a:pPr>
+            <a:r>
+              <a:rPr>
+                <a:ea typeface="Microsoft JhengHei"/>
+              </a:rPr>
+              <a:t>課程名稱：非結構型資料的分析案例</a:t>
+            </a:r>
+          </a:p>
+        </p:txBody>
+      </p:sp>
+      <p:sp>
+        <p:nvSpPr>
+          <p:cNvPr id="7" name="TextBox 6"/>
+          <p:cNvSpPr txBox="1"/>
+          <p:nvPr/>
+        </p:nvSpPr>
+        <p:spPr>
+          <a:xfrm>
             <a:off x="594360" y="5184648"/>
             <a:ext cx="4572000" cy="365760"/>
           </a:xfrm>
@@ -4659,14 +4701,14 @@
       </p:sp>
       <p:sp>
         <p:nvSpPr>
-          <p:cNvPr id="7" name="TextBox 6"/>
+          <p:cNvPr id="8" name="TextBox 7"/>
           <p:cNvSpPr txBox="1"/>
           <p:nvPr/>
         </p:nvSpPr>
         <p:spPr>
           <a:xfrm>
             <a:off x="594360" y="5632704"/>
-            <a:ext cx="4572000" cy="365760"/>
+            <a:ext cx="5212080" cy="365760"/>
           </a:xfrm>
           <a:prstGeom prst="rect">
             <a:avLst/>
@@ -4694,14 +4736,14 @@
               <a:rPr>
                 <a:ea typeface="Microsoft JhengHei"/>
               </a:rPr>
-              <a:t>專案結案報告  ·  2026.09</a:t>
+              <a:t>專案結案報告  ·  2026 年 9 月 8 日</a:t>
             </a:r>
           </a:p>
         </p:txBody>
       </p:sp>
       <p:pic>
         <p:nvPicPr>
-          <p:cNvPr id="8" name="Picture 7" descr="cover.png"/>
+          <p:cNvPr id="9" name="Picture 8" descr="cover.png"/>
           <p:cNvPicPr>
             <a:picLocks noChangeAspect="1"/>
           </p:cNvPicPr>
@@ -9633,7 +9675,7 @@
     <p:bg>
       <p:bgPr>
         <a:solidFill>
-          <a:srgbClr val="173D32"/>
+          <a:srgbClr val="F5F0E6"/>
         </a:solidFill>
         <a:effectLst/>
       </p:bgPr>
@@ -9673,7 +9715,7 @@
               </a:spcAft>
               <a:defRPr sz="3500" b="1">
                 <a:solidFill>
-                  <a:srgbClr val="F5F0E6"/>
+                  <a:srgbClr val="173D32"/>
                 </a:solidFill>
                 <a:latin typeface="Microsoft JhengHei"/>
               </a:defRPr>
@@ -9715,7 +9757,7 @@
               </a:spcAft>
               <a:defRPr sz="1000" b="0">
                 <a:solidFill>
-                  <a:srgbClr val="E8E4D8"/>
+                  <a:srgbClr val="586B62"/>
                 </a:solidFill>
                 <a:latin typeface="Microsoft JhengHei"/>
               </a:defRPr>
@@ -9757,7 +9799,7 @@
               </a:spcAft>
               <a:defRPr sz="1400" b="0">
                 <a:solidFill>
-                  <a:srgbClr val="E8E4D8"/>
+                  <a:srgbClr val="586B62"/>
                 </a:solidFill>
                 <a:latin typeface="Microsoft JhengHei"/>
               </a:defRPr>
@@ -9799,7 +9841,7 @@
               </a:spcAft>
               <a:defRPr sz="6000" b="1">
                 <a:solidFill>
-                  <a:srgbClr val="F5F0E6"/>
+                  <a:srgbClr val="D75A43"/>
                 </a:solidFill>
                 <a:latin typeface="Microsoft JhengHei"/>
               </a:defRPr>
@@ -9841,7 +9883,7 @@
               </a:spcAft>
               <a:defRPr sz="1800" b="0">
                 <a:solidFill>
-                  <a:srgbClr val="E8E4D8"/>
+                  <a:srgbClr val="586B62"/>
                 </a:solidFill>
                 <a:latin typeface="Microsoft JhengHei"/>
               </a:defRPr>
@@ -9883,7 +9925,7 @@
               </a:spcAft>
               <a:defRPr sz="6000" b="1">
                 <a:solidFill>
-                  <a:srgbClr val="F5F0E6"/>
+                  <a:srgbClr val="D75A43"/>
                 </a:solidFill>
                 <a:latin typeface="Microsoft JhengHei"/>
               </a:defRPr>
@@ -9925,7 +9967,7 @@
               </a:spcAft>
               <a:defRPr sz="1800" b="0">
                 <a:solidFill>
-                  <a:srgbClr val="E8E4D8"/>
+                  <a:srgbClr val="586B62"/>
                 </a:solidFill>
                 <a:latin typeface="Microsoft JhengHei"/>
               </a:defRPr>
@@ -9967,7 +10009,7 @@
               </a:spcAft>
               <a:defRPr sz="2700" b="1">
                 <a:solidFill>
-                  <a:srgbClr val="F5F0E6"/>
+                  <a:srgbClr val="173D32"/>
                 </a:solidFill>
                 <a:latin typeface="Microsoft JhengHei"/>
               </a:defRPr>
@@ -10009,7 +10051,7 @@
               </a:spcAft>
               <a:defRPr sz="2000" b="0">
                 <a:solidFill>
-                  <a:srgbClr val="F5F0E6"/>
+                  <a:srgbClr val="173D32"/>
                 </a:solidFill>
                 <a:latin typeface="Microsoft JhengHei"/>
               </a:defRPr>
@@ -10051,7 +10093,7 @@
               </a:spcAft>
               <a:defRPr sz="2000" b="0">
                 <a:solidFill>
-                  <a:srgbClr val="F5F0E6"/>
+                  <a:srgbClr val="173D32"/>
                 </a:solidFill>
                 <a:latin typeface="Microsoft JhengHei"/>
               </a:defRPr>
@@ -10093,7 +10135,7 @@
               </a:spcAft>
               <a:defRPr sz="1700" b="0">
                 <a:solidFill>
-                  <a:srgbClr val="E8E4D8"/>
+                  <a:srgbClr val="586B62"/>
                 </a:solidFill>
                 <a:latin typeface="Microsoft JhengHei"/>
               </a:defRPr>
@@ -10135,7 +10177,7 @@
               </a:spcAft>
               <a:defRPr sz="1200" b="0">
                 <a:solidFill>
-                  <a:srgbClr val="E8E4D8"/>
+                  <a:srgbClr val="586B62"/>
                 </a:solidFill>
                 <a:latin typeface="Microsoft JhengHei"/>
               </a:defRPr>
@@ -10179,7 +10221,7 @@
               </a:spcAft>
               <a:defRPr sz="1400" b="0">
                 <a:solidFill>
-                  <a:srgbClr val="E8E4D8"/>
+                  <a:srgbClr val="586B62"/>
                 </a:solidFill>
                 <a:latin typeface="Microsoft JhengHei"/>
               </a:defRPr>

</xml_diff>